<commit_message>
docs: remove cost references and war stories slide from presentation
</commit_message>
<xml_diff>
--- a/docs/oompa-presentation.pptx
+++ b/docs/oompa-presentation.pptx
@@ -26,7 +26,6 @@
     <p:sldId id="274" r:id="rId26"/>
     <p:sldId id="275" r:id="rId27"/>
     <p:sldId id="276" r:id="rId28"/>
-    <p:sldId id="277" r:id="rId29"/>
   </p:sldIdLst>
   <p:sldSz cx="12191695" cy="6858000" type="screen4x3"/>
   <p:notesSz cx="6858000" cy="9144000"/>
@@ -733,7 +732,7 @@
           <a:lstStyle/>
           <a:p>
             <a:r>
-              <a:t>Keep this quick -- 2 minutes max. The social mistake was the bigger lesson. "And on top of the social mistake, the code had bugs too."</a:t>
+              <a:t>Point at the dial. "ovn-k is report-only because I moved it there AFTER I realized nobody asked for it. The only project with full autonomy is oompa itself."</a:t>
             </a:r>
           </a:p>
         </p:txBody>
@@ -803,7 +802,7 @@
           <a:lstStyle/>
           <a:p>
             <a:r>
-              <a:t>Point at the dial. "ovn-k is report-only because I moved it there AFTER I realized nobody asked for it. The only project with full autonomy is oompa itself."</a:t>
+              <a:t>SHOW SLACK: Open your Slack channel and show a real oompa report. "This is what report-only looks like. I get visibility. Nobody's PR gets touched." End with the quote. Let it land.</a:t>
             </a:r>
           </a:p>
         </p:txBody>
@@ -873,76 +872,6 @@
           <a:lstStyle/>
           <a:p>
             <a:r>
-              <a:t>SHOW SLACK: Open your Slack channel and show a real oompa report. "This is what report-only looks like. I get visibility. Nobody's PR gets touched." End with the quote. Let it land.</a:t>
-            </a:r>
-          </a:p>
-        </p:txBody>
-      </p:sp>
-      <p:sp>
-        <p:nvSpPr>
-          <p:cNvPr id="4" name="Slide Number Placeholder 3"/>
-          <p:cNvSpPr>
-            <a:spLocks noGrp="1"/>
-          </p:cNvSpPr>
-          <p:nvPr>
-            <p:ph type="sldNum" idx="5" sz="quarter"/>
-          </p:nvPr>
-        </p:nvSpPr>
-        <p:spPr/>
-      </p:sp>
-    </p:spTree>
-  </p:cSld>
-  <p:clrMapOvr>
-    <a:masterClrMapping/>
-  </p:clrMapOvr>
-</p:notes>
-</file>
-
-<file path=ppt/notesSlides/notesSlide15.xml><?xml version="1.0" encoding="utf-8"?>
-<p:notes xmlns:a="http://schemas.openxmlformats.org/drawingml/2006/main" xmlns:p="http://schemas.openxmlformats.org/presentationml/2006/main" xmlns:r="http://schemas.openxmlformats.org/officeDocument/2006/relationships">
-  <p:cSld>
-    <p:spTree>
-      <p:nvGrpSpPr>
-        <p:cNvPr id="1" name=""/>
-        <p:cNvGrpSpPr/>
-        <p:nvPr/>
-      </p:nvGrpSpPr>
-      <p:grpSpPr>
-        <a:xfrm>
-          <a:off x="0" y="0"/>
-          <a:ext cx="0" cy="0"/>
-          <a:chOff x="0" y="0"/>
-          <a:chExt cx="0" cy="0"/>
-        </a:xfrm>
-      </p:grpSpPr>
-      <p:sp>
-        <p:nvSpPr>
-          <p:cNvPr id="2" name="Slide Image Placeholder 1"/>
-          <p:cNvSpPr>
-            <a:spLocks noGrp="1"/>
-          </p:cNvSpPr>
-          <p:nvPr>
-            <p:ph type="sldImg" idx="2"/>
-          </p:nvPr>
-        </p:nvSpPr>
-        <p:spPr/>
-      </p:sp>
-      <p:sp>
-        <p:nvSpPr>
-          <p:cNvPr id="3" name="Notes Placeholder 2"/>
-          <p:cNvSpPr>
-            <a:spLocks noGrp="1"/>
-          </p:cNvSpPr>
-          <p:nvPr>
-            <p:ph type="body" idx="3" sz="quarter"/>
-          </p:nvPr>
-        </p:nvSpPr>
-        <p:spPr/>
-        <p:txBody>
-          <a:bodyPr/>
-          <a:lstStyle/>
-          <a:p>
-            <a:r>
               <a:t>SSH into the machine. Run the TUI. Walk through each project box. Point out which oompas are sleeping vs working. Open Slack, show a real report. Run: oompa status --events --project=nmstate. Take questions while pointing at the screen.</a:t>
             </a:r>
           </a:p>
@@ -1379,11 +1308,6 @@
           <a:p>
             <a:r>
               <a:t>Show the review comment reply. Show the CI analysis.</a:t>
-            </a:r>
-          </a:p>
-          <a:p>
-            <a:r>
-              <a:t>Transition: "And this is also where oompa got stuck in a loop."</a:t>
             </a:r>
           </a:p>
         </p:txBody>
@@ -4836,7 +4760,7 @@
                 </a:solidFill>
                 <a:latin typeface="Calibri"/>
               </a:rPr>
-              <a:t>  where the cost incident started</a:t>
+              <a:t>  full autonomous mode</a:t>
             </a:r>
           </a:p>
         </p:txBody>
@@ -5161,42 +5085,6 @@
             </a:pPr>
             <a:r>
               <a:t>Retests -- /test e2e-kubevirt-aws-ovn</a:t>
-            </a:r>
-          </a:p>
-        </p:txBody>
-      </p:sp>
-      <p:sp>
-        <p:nvSpPr>
-          <p:cNvPr id="10" name="TextBox 9"/>
-          <p:cNvSpPr txBox="1"/>
-          <p:nvPr/>
-        </p:nvSpPr>
-        <p:spPr>
-          <a:xfrm>
-            <a:off x="731520" y="5303520"/>
-            <a:ext cx="10698480" cy="548640"/>
-          </a:xfrm>
-          <a:prstGeom prst="rect">
-            <a:avLst/>
-          </a:prstGeom>
-          <a:noFill/>
-        </p:spPr>
-        <p:txBody>
-          <a:bodyPr wrap="square">
-            <a:spAutoFit/>
-          </a:bodyPr>
-          <a:lstStyle/>
-          <a:p>
-            <a:pPr algn="l">
-              <a:defRPr sz="2200" b="1">
-                <a:solidFill>
-                  <a:srgbClr val="EC7A08"/>
-                </a:solidFill>
-                <a:latin typeface="Calibri"/>
-              </a:defRPr>
-            </a:pPr>
-            <a:r>
-              <a:t>This is also where the review retry loop burned ~$2-4k in 5 days.</a:t>
             </a:r>
           </a:p>
         </p:txBody>
@@ -6951,8 +6839,44 @@
         </p:nvSpPr>
         <p:spPr>
           <a:xfrm>
-            <a:off x="731520" y="365760"/>
-            <a:ext cx="10698480" cy="822960"/>
+            <a:off x="914400" y="1371600"/>
+            <a:ext cx="10332720" cy="1828800"/>
+          </a:xfrm>
+          <a:prstGeom prst="rect">
+            <a:avLst/>
+          </a:prstGeom>
+          <a:noFill/>
+        </p:spPr>
+        <p:txBody>
+          <a:bodyPr wrap="none">
+            <a:spAutoFit/>
+          </a:bodyPr>
+          <a:lstStyle/>
+          <a:p>
+            <a:pPr algn="ctr">
+              <a:defRPr sz="9600" b="1">
+                <a:solidFill>
+                  <a:srgbClr val="550000"/>
+                </a:solidFill>
+                <a:latin typeface="Calibri"/>
+              </a:defRPr>
+            </a:pPr>
+            <a:r>
+              <a:t>05</a:t>
+            </a:r>
+          </a:p>
+        </p:txBody>
+      </p:sp>
+      <p:sp>
+        <p:nvSpPr>
+          <p:cNvPr id="4" name="TextBox 3"/>
+          <p:cNvSpPr txBox="1"/>
+          <p:nvPr/>
+        </p:nvSpPr>
+        <p:spPr>
+          <a:xfrm>
+            <a:off x="914400" y="3200400"/>
+            <a:ext cx="10332720" cy="1097280"/>
           </a:xfrm>
           <a:prstGeom prst="rect">
             <a:avLst/>
@@ -6965,8 +6889,8 @@
           </a:bodyPr>
           <a:lstStyle/>
           <a:p>
-            <a:pPr algn="l">
-              <a:defRPr sz="3600" b="1">
+            <a:pPr algn="ctr">
+              <a:defRPr sz="4800" b="1">
                 <a:solidFill>
                   <a:srgbClr val="FFFFFF"/>
                 </a:solidFill>
@@ -6974,217 +6898,7 @@
               </a:defRPr>
             </a:pPr>
             <a:r>
-              <a:t>The technical mistakes</a:t>
-            </a:r>
-          </a:p>
-        </p:txBody>
-      </p:sp>
-      <p:sp>
-        <p:nvSpPr>
-          <p:cNvPr id="4" name="Rectangle 3"/>
-          <p:cNvSpPr/>
-          <p:nvPr/>
-        </p:nvSpPr>
-        <p:spPr>
-          <a:xfrm>
-            <a:off x="731520" y="1371600"/>
-            <a:ext cx="5029200" cy="3200400"/>
-          </a:xfrm>
-          <a:prstGeom prst="rect">
-            <a:avLst/>
-          </a:prstGeom>
-          <a:solidFill>
-            <a:srgbClr val="1A140A"/>
-          </a:solidFill>
-          <a:ln>
-            <a:solidFill>
-              <a:srgbClr val="552E00"/>
-            </a:solidFill>
-          </a:ln>
-        </p:spPr>
-        <p:style>
-          <a:lnRef idx="1">
-            <a:schemeClr val="accent1"/>
-          </a:lnRef>
-          <a:fillRef idx="3">
-            <a:schemeClr val="accent1"/>
-          </a:fillRef>
-          <a:effectRef idx="2">
-            <a:schemeClr val="accent1"/>
-          </a:effectRef>
-          <a:fontRef idx="minor">
-            <a:schemeClr val="lt1"/>
-          </a:fontRef>
-        </p:style>
-        <p:txBody>
-          <a:bodyPr rtlCol="0" anchor="ctr" wrap="square"/>
-          <a:lstStyle/>
-          <a:p>
-            <a:pPr algn="ctr">
-              <a:defRPr sz="2200" b="1">
-                <a:solidFill>
-                  <a:srgbClr val="EC7A08"/>
-                </a:solidFill>
-                <a:latin typeface="Calibri"/>
-              </a:defRPr>
-            </a:pPr>
-            <a:r>
-              <a:t>$2-4k review retry loop</a:t>
-            </a:r>
-          </a:p>
-          <a:p>
-            <a:pPr>
-              <a:spcBef>
-                <a:spcPts val="1200"/>
-              </a:spcBef>
-              <a:defRPr sz="1800">
-                <a:solidFill>
-                  <a:srgbClr val="F2F2F2"/>
-                </a:solidFill>
-                <a:latin typeface="Calibri"/>
-              </a:defRPr>
-            </a:pPr>
-            <a:r>
-              <a:t>Oompa got stuck trying to address the same review comment over and over on hypershift. 5 days. No cost guard.</a:t>
-            </a:r>
-          </a:p>
-          <a:p>
-            <a:pPr>
-              <a:spcBef>
-                <a:spcPts val="1200"/>
-              </a:spcBef>
-              <a:defRPr sz="1800" b="1">
-                <a:solidFill>
-                  <a:srgbClr val="FFFFFF"/>
-                </a:solidFill>
-                <a:latin typeface="Calibri"/>
-              </a:defRPr>
-            </a:pPr>
-            <a:r>
-              <a:t>Fix: retry counter, no-op detection, cost guard per PR.</a:t>
-            </a:r>
-          </a:p>
-        </p:txBody>
-      </p:sp>
-      <p:sp>
-        <p:nvSpPr>
-          <p:cNvPr id="5" name="Rectangle 4"/>
-          <p:cNvSpPr/>
-          <p:nvPr/>
-        </p:nvSpPr>
-        <p:spPr>
-          <a:xfrm>
-            <a:off x="6400800" y="1371600"/>
-            <a:ext cx="5029200" cy="3200400"/>
-          </a:xfrm>
-          <a:prstGeom prst="rect">
-            <a:avLst/>
-          </a:prstGeom>
-          <a:solidFill>
-            <a:srgbClr val="1A140A"/>
-          </a:solidFill>
-          <a:ln>
-            <a:solidFill>
-              <a:srgbClr val="552E00"/>
-            </a:solidFill>
-          </a:ln>
-        </p:spPr>
-        <p:style>
-          <a:lnRef idx="1">
-            <a:schemeClr val="accent1"/>
-          </a:lnRef>
-          <a:fillRef idx="3">
-            <a:schemeClr val="accent1"/>
-          </a:fillRef>
-          <a:effectRef idx="2">
-            <a:schemeClr val="accent1"/>
-          </a:effectRef>
-          <a:fontRef idx="minor">
-            <a:schemeClr val="lt1"/>
-          </a:fontRef>
-        </p:style>
-        <p:txBody>
-          <a:bodyPr rtlCol="0" anchor="ctr" wrap="square"/>
-          <a:lstStyle/>
-          <a:p>
-            <a:pPr algn="ctr">
-              <a:defRPr sz="2200" b="1">
-                <a:solidFill>
-                  <a:srgbClr val="EC7A08"/>
-                </a:solidFill>
-                <a:latin typeface="Calibri"/>
-              </a:defRPr>
-            </a:pPr>
-            <a:r>
-              <a:t>Wrong issue dedup</a:t>
-            </a:r>
-          </a:p>
-          <a:p>
-            <a:pPr>
-              <a:spcBef>
-                <a:spcPts val="1200"/>
-              </a:spcBef>
-              <a:defRPr sz="1800">
-                <a:solidFill>
-                  <a:srgbClr val="F2F2F2"/>
-                </a:solidFill>
-                <a:latin typeface="Calibri"/>
-              </a:defRPr>
-            </a:pPr>
-            <a:r>
-              <a:t>CRI-O mirror 404 matched a VLAN test failure issue -- because dedup only checked the job name, not the failure content.</a:t>
-            </a:r>
-          </a:p>
-          <a:p>
-            <a:pPr>
-              <a:spcBef>
-                <a:spcPts val="1200"/>
-              </a:spcBef>
-              <a:defRPr sz="1800" b="1">
-                <a:solidFill>
-                  <a:srgbClr val="FFFFFF"/>
-                </a:solidFill>
-                <a:latin typeface="Calibri"/>
-              </a:defRPr>
-            </a:pPr>
-            <a:r>
-              <a:t>Fix: content-aware matching with failure signatures. (PR #193 -- the self-fix you just saw)</a:t>
-            </a:r>
-          </a:p>
-        </p:txBody>
-      </p:sp>
-      <p:sp>
-        <p:nvSpPr>
-          <p:cNvPr id="6" name="TextBox 5"/>
-          <p:cNvSpPr txBox="1"/>
-          <p:nvPr/>
-        </p:nvSpPr>
-        <p:spPr>
-          <a:xfrm>
-            <a:off x="731520" y="5029200"/>
-            <a:ext cx="10698480" cy="548640"/>
-          </a:xfrm>
-          <a:prstGeom prst="rect">
-            <a:avLst/>
-          </a:prstGeom>
-          <a:noFill/>
-        </p:spPr>
-        <p:txBody>
-          <a:bodyPr wrap="square">
-            <a:spAutoFit/>
-          </a:bodyPr>
-          <a:lstStyle/>
-          <a:p>
-            <a:pPr algn="l">
-              <a:defRPr sz="2000" b="0">
-                <a:solidFill>
-                  <a:srgbClr val="6A6E73"/>
-                </a:solidFill>
-                <a:latin typeface="Calibri"/>
-              </a:defRPr>
-            </a:pPr>
-            <a:r>
-              <a:t>Every failure taught me something. Every guardrail was added after something broke.</a:t>
+              <a:t>Where I am now</a:t>
             </a:r>
           </a:p>
         </p:txBody>
@@ -7266,44 +6980,8 @@
         </p:nvSpPr>
         <p:spPr>
           <a:xfrm>
-            <a:off x="914400" y="1371600"/>
-            <a:ext cx="10332720" cy="1828800"/>
-          </a:xfrm>
-          <a:prstGeom prst="rect">
-            <a:avLst/>
-          </a:prstGeom>
-          <a:noFill/>
-        </p:spPr>
-        <p:txBody>
-          <a:bodyPr wrap="none">
-            <a:spAutoFit/>
-          </a:bodyPr>
-          <a:lstStyle/>
-          <a:p>
-            <a:pPr algn="ctr">
-              <a:defRPr sz="9600" b="1">
-                <a:solidFill>
-                  <a:srgbClr val="550000"/>
-                </a:solidFill>
-                <a:latin typeface="Calibri"/>
-              </a:defRPr>
-            </a:pPr>
-            <a:r>
-              <a:t>05</a:t>
-            </a:r>
-          </a:p>
-        </p:txBody>
-      </p:sp>
-      <p:sp>
-        <p:nvSpPr>
-          <p:cNvPr id="4" name="TextBox 3"/>
-          <p:cNvSpPr txBox="1"/>
-          <p:nvPr/>
-        </p:nvSpPr>
-        <p:spPr>
-          <a:xfrm>
-            <a:off x="914400" y="3200400"/>
-            <a:ext cx="10332720" cy="1097280"/>
+            <a:off x="731520" y="365760"/>
+            <a:ext cx="10698480" cy="822960"/>
           </a:xfrm>
           <a:prstGeom prst="rect">
             <a:avLst/>
@@ -7316,8 +6994,63 @@
           </a:bodyPr>
           <a:lstStyle/>
           <a:p>
+            <a:pPr algn="l">
+              <a:defRPr sz="3600" b="1">
+                <a:solidFill>
+                  <a:srgbClr val="FFFFFF"/>
+                </a:solidFill>
+                <a:latin typeface="Calibri"/>
+              </a:defRPr>
+            </a:pPr>
+            <a:r>
+              <a:t>The dial</a:t>
+            </a:r>
+          </a:p>
+        </p:txBody>
+      </p:sp>
+      <p:sp>
+        <p:nvSpPr>
+          <p:cNvPr id="4" name="Rectangle 3"/>
+          <p:cNvSpPr/>
+          <p:nvPr/>
+        </p:nvSpPr>
+        <p:spPr>
+          <a:xfrm>
+            <a:off x="731520" y="1371600"/>
+            <a:ext cx="2560320" cy="1188720"/>
+          </a:xfrm>
+          <a:prstGeom prst="rect">
+            <a:avLst/>
+          </a:prstGeom>
+          <a:solidFill>
+            <a:srgbClr val="2A2A2A"/>
+          </a:solidFill>
+          <a:ln>
+            <a:solidFill>
+              <a:srgbClr val="6A6E73"/>
+            </a:solidFill>
+          </a:ln>
+        </p:spPr>
+        <p:style>
+          <a:lnRef idx="1">
+            <a:schemeClr val="accent1"/>
+          </a:lnRef>
+          <a:fillRef idx="3">
+            <a:schemeClr val="accent1"/>
+          </a:fillRef>
+          <a:effectRef idx="2">
+            <a:schemeClr val="accent1"/>
+          </a:effectRef>
+          <a:fontRef idx="minor">
+            <a:schemeClr val="lt1"/>
+          </a:fontRef>
+        </p:style>
+        <p:txBody>
+          <a:bodyPr rtlCol="0" anchor="ctr" wrap="square"/>
+          <a:lstStyle/>
+          <a:p>
             <a:pPr algn="ctr">
-              <a:defRPr sz="4800" b="1">
+              <a:defRPr sz="2000" b="1">
                 <a:solidFill>
                   <a:srgbClr val="FFFFFF"/>
                 </a:solidFill>
@@ -7325,7 +7058,345 @@
               </a:defRPr>
             </a:pPr>
             <a:r>
-              <a:t>Where I am now</a:t>
+              <a:t>Report only</a:t>
+            </a:r>
+          </a:p>
+          <a:p>
+            <a:pPr algn="ctr">
+              <a:spcBef>
+                <a:spcPts val="800"/>
+              </a:spcBef>
+              <a:defRPr sz="1600">
+                <a:solidFill>
+                  <a:srgbClr val="6A6E73"/>
+                </a:solidFill>
+                <a:latin typeface="Calibri"/>
+              </a:defRPr>
+            </a:pPr>
+            <a:r>
+              <a:t>ovn-kubernetes</a:t>
+            </a:r>
+          </a:p>
+        </p:txBody>
+      </p:sp>
+      <p:sp>
+        <p:nvSpPr>
+          <p:cNvPr id="5" name="Rectangle 4"/>
+          <p:cNvSpPr/>
+          <p:nvPr/>
+        </p:nvSpPr>
+        <p:spPr>
+          <a:xfrm>
+            <a:off x="3383280" y="1371600"/>
+            <a:ext cx="2560320" cy="1188720"/>
+          </a:xfrm>
+          <a:prstGeom prst="rect">
+            <a:avLst/>
+          </a:prstGeom>
+          <a:solidFill>
+            <a:srgbClr val="0A2A2A"/>
+          </a:solidFill>
+          <a:ln>
+            <a:solidFill>
+              <a:srgbClr val="009596"/>
+            </a:solidFill>
+          </a:ln>
+        </p:spPr>
+        <p:style>
+          <a:lnRef idx="1">
+            <a:schemeClr val="accent1"/>
+          </a:lnRef>
+          <a:fillRef idx="3">
+            <a:schemeClr val="accent1"/>
+          </a:fillRef>
+          <a:effectRef idx="2">
+            <a:schemeClr val="accent1"/>
+          </a:effectRef>
+          <a:fontRef idx="minor">
+            <a:schemeClr val="lt1"/>
+          </a:fontRef>
+        </p:style>
+        <p:txBody>
+          <a:bodyPr rtlCol="0" anchor="ctr" wrap="square"/>
+          <a:lstStyle/>
+          <a:p>
+            <a:pPr algn="ctr">
+              <a:defRPr sz="2000" b="1">
+                <a:solidFill>
+                  <a:srgbClr val="FFFFFF"/>
+                </a:solidFill>
+                <a:latin typeface="Calibri"/>
+              </a:defRPr>
+            </a:pPr>
+            <a:r>
+              <a:t>Triage + Rebase</a:t>
+            </a:r>
+          </a:p>
+          <a:p>
+            <a:pPr algn="ctr">
+              <a:spcBef>
+                <a:spcPts val="800"/>
+              </a:spcBef>
+              <a:defRPr sz="1600">
+                <a:solidFill>
+                  <a:srgbClr val="6A6E73"/>
+                </a:solidFill>
+                <a:latin typeface="Calibri"/>
+              </a:defRPr>
+            </a:pPr>
+            <a:r>
+              <a:t>kubernetes-nmstate</a:t>
+            </a:r>
+          </a:p>
+        </p:txBody>
+      </p:sp>
+      <p:sp>
+        <p:nvSpPr>
+          <p:cNvPr id="6" name="Rectangle 5"/>
+          <p:cNvSpPr/>
+          <p:nvPr/>
+        </p:nvSpPr>
+        <p:spPr>
+          <a:xfrm>
+            <a:off x="6035040" y="1371600"/>
+            <a:ext cx="2560320" cy="1188720"/>
+          </a:xfrm>
+          <a:prstGeom prst="rect">
+            <a:avLst/>
+          </a:prstGeom>
+          <a:solidFill>
+            <a:srgbClr val="2A1E0A"/>
+          </a:solidFill>
+          <a:ln>
+            <a:solidFill>
+              <a:srgbClr val="F0AB00"/>
+            </a:solidFill>
+          </a:ln>
+        </p:spPr>
+        <p:style>
+          <a:lnRef idx="1">
+            <a:schemeClr val="accent1"/>
+          </a:lnRef>
+          <a:fillRef idx="3">
+            <a:schemeClr val="accent1"/>
+          </a:fillRef>
+          <a:effectRef idx="2">
+            <a:schemeClr val="accent1"/>
+          </a:effectRef>
+          <a:fontRef idx="minor">
+            <a:schemeClr val="lt1"/>
+          </a:fontRef>
+        </p:style>
+        <p:txBody>
+          <a:bodyPr rtlCol="0" anchor="ctr" wrap="square"/>
+          <a:lstStyle/>
+          <a:p>
+            <a:pPr algn="ctr">
+              <a:defRPr sz="2000" b="1">
+                <a:solidFill>
+                  <a:srgbClr val="FFFFFF"/>
+                </a:solidFill>
+                <a:latin typeface="Calibri"/>
+              </a:defRPr>
+            </a:pPr>
+            <a:r>
+              <a:t>CI + Reviews</a:t>
+            </a:r>
+          </a:p>
+          <a:p>
+            <a:pPr algn="ctr">
+              <a:spcBef>
+                <a:spcPts val="800"/>
+              </a:spcBef>
+              <a:defRPr sz="1600">
+                <a:solidFill>
+                  <a:srgbClr val="6A6E73"/>
+                </a:solidFill>
+                <a:latin typeface="Calibri"/>
+              </a:defRPr>
+            </a:pPr>
+            <a:r>
+              <a:t>virt-tests</a:t>
+            </a:r>
+          </a:p>
+        </p:txBody>
+      </p:sp>
+      <p:sp>
+        <p:nvSpPr>
+          <p:cNvPr id="7" name="Rectangle 6"/>
+          <p:cNvSpPr/>
+          <p:nvPr/>
+        </p:nvSpPr>
+        <p:spPr>
+          <a:xfrm>
+            <a:off x="8686800" y="1371600"/>
+            <a:ext cx="2560320" cy="1188720"/>
+          </a:xfrm>
+          <a:prstGeom prst="rect">
+            <a:avLst/>
+          </a:prstGeom>
+          <a:solidFill>
+            <a:srgbClr val="2A0A0A"/>
+          </a:solidFill>
+          <a:ln>
+            <a:solidFill>
+              <a:srgbClr val="EE0000"/>
+            </a:solidFill>
+          </a:ln>
+        </p:spPr>
+        <p:style>
+          <a:lnRef idx="1">
+            <a:schemeClr val="accent1"/>
+          </a:lnRef>
+          <a:fillRef idx="3">
+            <a:schemeClr val="accent1"/>
+          </a:fillRef>
+          <a:effectRef idx="2">
+            <a:schemeClr val="accent1"/>
+          </a:effectRef>
+          <a:fontRef idx="minor">
+            <a:schemeClr val="lt1"/>
+          </a:fontRef>
+        </p:style>
+        <p:txBody>
+          <a:bodyPr rtlCol="0" anchor="ctr" wrap="square"/>
+          <a:lstStyle/>
+          <a:p>
+            <a:pPr algn="ctr">
+              <a:defRPr sz="2000" b="1">
+                <a:solidFill>
+                  <a:srgbClr val="FFFFFF"/>
+                </a:solidFill>
+                <a:latin typeface="Calibri"/>
+              </a:defRPr>
+            </a:pPr>
+            <a:r>
+              <a:t>Self-maintaining</a:t>
+            </a:r>
+          </a:p>
+          <a:p>
+            <a:pPr algn="ctr">
+              <a:spcBef>
+                <a:spcPts val="800"/>
+              </a:spcBef>
+              <a:defRPr sz="1600">
+                <a:solidFill>
+                  <a:srgbClr val="6A6E73"/>
+                </a:solidFill>
+                <a:latin typeface="Calibri"/>
+              </a:defRPr>
+            </a:pPr>
+            <a:r>
+              <a:t>oompa</a:t>
+            </a:r>
+          </a:p>
+        </p:txBody>
+      </p:sp>
+      <p:sp>
+        <p:nvSpPr>
+          <p:cNvPr id="8" name="TextBox 7"/>
+          <p:cNvSpPr txBox="1"/>
+          <p:nvPr/>
+        </p:nvSpPr>
+        <p:spPr>
+          <a:xfrm>
+            <a:off x="731520" y="3017520"/>
+            <a:ext cx="10698480" cy="3200400"/>
+          </a:xfrm>
+          <a:prstGeom prst="rect">
+            <a:avLst/>
+          </a:prstGeom>
+          <a:noFill/>
+        </p:spPr>
+        <p:txBody>
+          <a:bodyPr wrap="square">
+            <a:spAutoFit/>
+          </a:bodyPr>
+          <a:lstStyle/>
+          <a:p>
+            <a:pPr algn="l">
+              <a:defRPr sz="2200" b="0">
+                <a:solidFill>
+                  <a:srgbClr val="F2F2F2"/>
+                </a:solidFill>
+                <a:latin typeface="Calibri"/>
+              </a:defRPr>
+            </a:pPr>
+          </a:p>
+          <a:p>
+            <a:pPr>
+              <a:spcBef>
+                <a:spcPts val="600"/>
+              </a:spcBef>
+              <a:spcAft>
+                <a:spcPts val="400"/>
+              </a:spcAft>
+              <a:defRPr sz="2200" b="1">
+                <a:solidFill>
+                  <a:srgbClr val="F2F2F2"/>
+                </a:solidFill>
+                <a:latin typeface="Calibri"/>
+              </a:defRPr>
+            </a:pPr>
+            <a:r>
+              <a:t>Report-only where I don't have permission or trust yet</a:t>
+            </a:r>
+          </a:p>
+          <a:p>
+            <a:pPr>
+              <a:spcBef>
+                <a:spcPts val="600"/>
+              </a:spcBef>
+              <a:spcAft>
+                <a:spcPts val="400"/>
+              </a:spcAft>
+              <a:defRPr sz="2200" b="1">
+                <a:solidFill>
+                  <a:srgbClr val="F2F2F2"/>
+                </a:solidFill>
+                <a:latin typeface="Calibri"/>
+              </a:defRPr>
+            </a:pPr>
+            <a:r>
+              <a:t>Full automation only on my own project</a:t>
+            </a:r>
+          </a:p>
+          <a:p>
+            <a:pPr>
+              <a:spcBef>
+                <a:spcPts val="600"/>
+              </a:spcBef>
+              <a:spcAft>
+                <a:spcPts val="400"/>
+              </a:spcAft>
+              <a:defRPr sz="2200" b="0">
+                <a:solidFill>
+                  <a:srgbClr val="F2F2F2"/>
+                </a:solidFill>
+                <a:latin typeface="Calibri"/>
+              </a:defRPr>
+            </a:pPr>
+            <a:r>
+              <a:t>The goal isn't "more automation everywhere"</a:t>
+            </a:r>
+          </a:p>
+          <a:p>
+            <a:pPr>
+              <a:spcBef>
+                <a:spcPts val="600"/>
+              </a:spcBef>
+              <a:spcAft>
+                <a:spcPts val="400"/>
+              </a:spcAft>
+              <a:defRPr sz="2200" b="1">
+                <a:solidFill>
+                  <a:srgbClr val="F2F2F2"/>
+                </a:solidFill>
+                <a:latin typeface="Calibri"/>
+              </a:defRPr>
+            </a:pPr>
+            <a:r>
+              <a:t>It's the right amount, with consent</a:t>
             </a:r>
           </a:p>
         </p:txBody>
@@ -7430,305 +7501,21 @@
               </a:defRPr>
             </a:pPr>
             <a:r>
-              <a:t>The dial</a:t>
-            </a:r>
-          </a:p>
-        </p:txBody>
-      </p:sp>
-      <p:sp>
-        <p:nvSpPr>
-          <p:cNvPr id="4" name="Rectangle 3"/>
-          <p:cNvSpPr/>
-          <p:nvPr/>
-        </p:nvSpPr>
-        <p:spPr>
-          <a:xfrm>
-            <a:off x="731520" y="1371600"/>
-            <a:ext cx="2560320" cy="1188720"/>
-          </a:xfrm>
-          <a:prstGeom prst="rect">
-            <a:avLst/>
-          </a:prstGeom>
-          <a:solidFill>
-            <a:srgbClr val="2A2A2A"/>
-          </a:solidFill>
-          <a:ln>
-            <a:solidFill>
-              <a:srgbClr val="6A6E73"/>
-            </a:solidFill>
-          </a:ln>
-        </p:spPr>
-        <p:style>
-          <a:lnRef idx="1">
-            <a:schemeClr val="accent1"/>
-          </a:lnRef>
-          <a:fillRef idx="3">
-            <a:schemeClr val="accent1"/>
-          </a:fillRef>
-          <a:effectRef idx="2">
-            <a:schemeClr val="accent1"/>
-          </a:effectRef>
-          <a:fontRef idx="minor">
-            <a:schemeClr val="lt1"/>
-          </a:fontRef>
-        </p:style>
-        <p:txBody>
-          <a:bodyPr rtlCol="0" anchor="ctr" wrap="square"/>
-          <a:lstStyle/>
-          <a:p>
-            <a:pPr algn="ctr">
-              <a:defRPr sz="2000" b="1">
-                <a:solidFill>
-                  <a:srgbClr val="FFFFFF"/>
-                </a:solidFill>
-                <a:latin typeface="Calibri"/>
-              </a:defRPr>
-            </a:pPr>
-            <a:r>
-              <a:t>Report only</a:t>
-            </a:r>
-          </a:p>
-          <a:p>
-            <a:pPr algn="ctr">
-              <a:spcBef>
-                <a:spcPts val="800"/>
-              </a:spcBef>
-              <a:defRPr sz="1600">
-                <a:solidFill>
-                  <a:srgbClr val="6A6E73"/>
-                </a:solidFill>
-                <a:latin typeface="Calibri"/>
-              </a:defRPr>
-            </a:pPr>
-            <a:r>
-              <a:t>ovn-kubernetes</a:t>
-            </a:r>
-          </a:p>
-        </p:txBody>
-      </p:sp>
-      <p:sp>
-        <p:nvSpPr>
-          <p:cNvPr id="5" name="Rectangle 4"/>
-          <p:cNvSpPr/>
-          <p:nvPr/>
-        </p:nvSpPr>
-        <p:spPr>
-          <a:xfrm>
-            <a:off x="3383280" y="1371600"/>
-            <a:ext cx="2560320" cy="1188720"/>
-          </a:xfrm>
-          <a:prstGeom prst="rect">
-            <a:avLst/>
-          </a:prstGeom>
-          <a:solidFill>
-            <a:srgbClr val="0A2A2A"/>
-          </a:solidFill>
-          <a:ln>
-            <a:solidFill>
-              <a:srgbClr val="009596"/>
-            </a:solidFill>
-          </a:ln>
-        </p:spPr>
-        <p:style>
-          <a:lnRef idx="1">
-            <a:schemeClr val="accent1"/>
-          </a:lnRef>
-          <a:fillRef idx="3">
-            <a:schemeClr val="accent1"/>
-          </a:fillRef>
-          <a:effectRef idx="2">
-            <a:schemeClr val="accent1"/>
-          </a:effectRef>
-          <a:fontRef idx="minor">
-            <a:schemeClr val="lt1"/>
-          </a:fontRef>
-        </p:style>
-        <p:txBody>
-          <a:bodyPr rtlCol="0" anchor="ctr" wrap="square"/>
-          <a:lstStyle/>
-          <a:p>
-            <a:pPr algn="ctr">
-              <a:defRPr sz="2000" b="1">
-                <a:solidFill>
-                  <a:srgbClr val="FFFFFF"/>
-                </a:solidFill>
-                <a:latin typeface="Calibri"/>
-              </a:defRPr>
-            </a:pPr>
-            <a:r>
-              <a:t>Triage + Rebase</a:t>
-            </a:r>
-          </a:p>
-          <a:p>
-            <a:pPr algn="ctr">
-              <a:spcBef>
-                <a:spcPts val="800"/>
-              </a:spcBef>
-              <a:defRPr sz="1600">
-                <a:solidFill>
-                  <a:srgbClr val="6A6E73"/>
-                </a:solidFill>
-                <a:latin typeface="Calibri"/>
-              </a:defRPr>
-            </a:pPr>
-            <a:r>
-              <a:t>kubernetes-nmstate</a:t>
-            </a:r>
-          </a:p>
-        </p:txBody>
-      </p:sp>
-      <p:sp>
-        <p:nvSpPr>
-          <p:cNvPr id="6" name="Rectangle 5"/>
-          <p:cNvSpPr/>
-          <p:nvPr/>
-        </p:nvSpPr>
-        <p:spPr>
-          <a:xfrm>
-            <a:off x="6035040" y="1371600"/>
-            <a:ext cx="2560320" cy="1188720"/>
-          </a:xfrm>
-          <a:prstGeom prst="rect">
-            <a:avLst/>
-          </a:prstGeom>
-          <a:solidFill>
-            <a:srgbClr val="2A1E0A"/>
-          </a:solidFill>
-          <a:ln>
-            <a:solidFill>
-              <a:srgbClr val="F0AB00"/>
-            </a:solidFill>
-          </a:ln>
-        </p:spPr>
-        <p:style>
-          <a:lnRef idx="1">
-            <a:schemeClr val="accent1"/>
-          </a:lnRef>
-          <a:fillRef idx="3">
-            <a:schemeClr val="accent1"/>
-          </a:fillRef>
-          <a:effectRef idx="2">
-            <a:schemeClr val="accent1"/>
-          </a:effectRef>
-          <a:fontRef idx="minor">
-            <a:schemeClr val="lt1"/>
-          </a:fontRef>
-        </p:style>
-        <p:txBody>
-          <a:bodyPr rtlCol="0" anchor="ctr" wrap="square"/>
-          <a:lstStyle/>
-          <a:p>
-            <a:pPr algn="ctr">
-              <a:defRPr sz="2000" b="1">
-                <a:solidFill>
-                  <a:srgbClr val="FFFFFF"/>
-                </a:solidFill>
-                <a:latin typeface="Calibri"/>
-              </a:defRPr>
-            </a:pPr>
-            <a:r>
-              <a:t>CI + Reviews</a:t>
-            </a:r>
-          </a:p>
-          <a:p>
-            <a:pPr algn="ctr">
-              <a:spcBef>
-                <a:spcPts val="800"/>
-              </a:spcBef>
-              <a:defRPr sz="1600">
-                <a:solidFill>
-                  <a:srgbClr val="6A6E73"/>
-                </a:solidFill>
-                <a:latin typeface="Calibri"/>
-              </a:defRPr>
-            </a:pPr>
-            <a:r>
-              <a:t>virt-tests</a:t>
-            </a:r>
-          </a:p>
-        </p:txBody>
-      </p:sp>
-      <p:sp>
-        <p:nvSpPr>
-          <p:cNvPr id="7" name="Rectangle 6"/>
-          <p:cNvSpPr/>
-          <p:nvPr/>
-        </p:nvSpPr>
-        <p:spPr>
-          <a:xfrm>
-            <a:off x="8686800" y="1371600"/>
-            <a:ext cx="2560320" cy="1188720"/>
-          </a:xfrm>
-          <a:prstGeom prst="rect">
-            <a:avLst/>
-          </a:prstGeom>
-          <a:solidFill>
-            <a:srgbClr val="2A0A0A"/>
-          </a:solidFill>
-          <a:ln>
-            <a:solidFill>
-              <a:srgbClr val="EE0000"/>
-            </a:solidFill>
-          </a:ln>
-        </p:spPr>
-        <p:style>
-          <a:lnRef idx="1">
-            <a:schemeClr val="accent1"/>
-          </a:lnRef>
-          <a:fillRef idx="3">
-            <a:schemeClr val="accent1"/>
-          </a:fillRef>
-          <a:effectRef idx="2">
-            <a:schemeClr val="accent1"/>
-          </a:effectRef>
-          <a:fontRef idx="minor">
-            <a:schemeClr val="lt1"/>
-          </a:fontRef>
-        </p:style>
-        <p:txBody>
-          <a:bodyPr rtlCol="0" anchor="ctr" wrap="square"/>
-          <a:lstStyle/>
-          <a:p>
-            <a:pPr algn="ctr">
-              <a:defRPr sz="2000" b="1">
-                <a:solidFill>
-                  <a:srgbClr val="FFFFFF"/>
-                </a:solidFill>
-                <a:latin typeface="Calibri"/>
-              </a:defRPr>
-            </a:pPr>
-            <a:r>
-              <a:t>Self-maintaining</a:t>
-            </a:r>
-          </a:p>
-          <a:p>
-            <a:pPr algn="ctr">
-              <a:spcBef>
-                <a:spcPts val="800"/>
-              </a:spcBef>
-              <a:defRPr sz="1600">
-                <a:solidFill>
-                  <a:srgbClr val="6A6E73"/>
-                </a:solidFill>
-                <a:latin typeface="Calibri"/>
-              </a:defRPr>
-            </a:pPr>
-            <a:r>
-              <a:t>oompa</a:t>
-            </a:r>
-          </a:p>
-        </p:txBody>
-      </p:sp>
-      <p:sp>
-        <p:nvSpPr>
-          <p:cNvPr id="8" name="TextBox 7"/>
+              <a:t>Being pragmatic</a:t>
+            </a:r>
+          </a:p>
+        </p:txBody>
+      </p:sp>
+      <p:sp>
+        <p:nvSpPr>
+          <p:cNvPr id="4" name="TextBox 3"/>
           <p:cNvSpPr txBox="1"/>
           <p:nvPr/>
         </p:nvSpPr>
         <p:spPr>
           <a:xfrm>
-            <a:off x="731520" y="3017520"/>
-            <a:ext cx="10698480" cy="3200400"/>
+            <a:off x="731520" y="1371600"/>
+            <a:ext cx="10698480" cy="2560320"/>
           </a:xfrm>
           <a:prstGeom prst="rect">
             <a:avLst/>
@@ -7742,7 +7529,7 @@
           <a:lstStyle/>
           <a:p>
             <a:pPr algn="l">
-              <a:defRPr sz="2200" b="0">
+              <a:defRPr sz="2400" b="0">
                 <a:solidFill>
                   <a:srgbClr val="F2F2F2"/>
                 </a:solidFill>
@@ -7758,7 +7545,7 @@
               <a:spcAft>
                 <a:spcPts val="400"/>
               </a:spcAft>
-              <a:defRPr sz="2200" b="1">
+              <a:defRPr sz="2400" b="0">
                 <a:solidFill>
                   <a:srgbClr val="F2F2F2"/>
                 </a:solidFill>
@@ -7766,7 +7553,7 @@
               </a:defRPr>
             </a:pPr>
             <a:r>
-              <a:t>Report-only where I don't have permission or trust yet</a:t>
+              <a:t>Slack reports give me visibility without touching anyone's PRs</a:t>
             </a:r>
           </a:p>
           <a:p>
@@ -7777,7 +7564,7 @@
               <a:spcAft>
                 <a:spcPts val="400"/>
               </a:spcAft>
-              <a:defRPr sz="2200" b="1">
+              <a:defRPr sz="2400" b="0">
                 <a:solidFill>
                   <a:srgbClr val="F2F2F2"/>
                 </a:solidFill>
@@ -7785,7 +7572,7 @@
               </a:defRPr>
             </a:pPr>
             <a:r>
-              <a:t>Full automation only on my own project</a:t>
+              <a:t>I ask before enabling actions on a project</a:t>
             </a:r>
           </a:p>
           <a:p>
@@ -7796,7 +7583,7 @@
               <a:spcAft>
                 <a:spcPts val="400"/>
               </a:spcAft>
-              <a:defRPr sz="2200" b="0">
+              <a:defRPr sz="2400" b="1">
                 <a:solidFill>
                   <a:srgbClr val="F2F2F2"/>
                 </a:solidFill>
@@ -7804,7 +7591,7 @@
               </a:defRPr>
             </a:pPr>
             <a:r>
-              <a:t>The goal isn't "more automation everywhere"</a:t>
+              <a:t>The tool has a dial because I learned I needed one</a:t>
             </a:r>
           </a:p>
           <a:p>
@@ -7815,7 +7602,7 @@
               <a:spcAft>
                 <a:spcPts val="400"/>
               </a:spcAft>
-              <a:defRPr sz="2200" b="1">
+              <a:defRPr sz="2400" b="1">
                 <a:solidFill>
                   <a:srgbClr val="F2F2F2"/>
                 </a:solidFill>
@@ -7823,7 +7610,66 @@
               </a:defRPr>
             </a:pPr>
             <a:r>
-              <a:t>It's the right amount, with consent</a:t>
+              <a:t>Don't enter AI psychosis. Be pragmatic.</a:t>
+            </a:r>
+          </a:p>
+        </p:txBody>
+      </p:sp>
+      <p:sp>
+        <p:nvSpPr>
+          <p:cNvPr id="5" name="Rectangle 4"/>
+          <p:cNvSpPr/>
+          <p:nvPr/>
+        </p:nvSpPr>
+        <p:spPr>
+          <a:xfrm>
+            <a:off x="1371600" y="4114800"/>
+            <a:ext cx="9418320" cy="1097280"/>
+          </a:xfrm>
+          <a:prstGeom prst="rect">
+            <a:avLst/>
+          </a:prstGeom>
+          <a:solidFill>
+            <a:srgbClr val="1A0A0A"/>
+          </a:solidFill>
+          <a:ln>
+            <a:solidFill>
+              <a:srgbClr val="550000"/>
+            </a:solidFill>
+          </a:ln>
+        </p:spPr>
+        <p:style>
+          <a:lnRef idx="1">
+            <a:schemeClr val="accent1"/>
+          </a:lnRef>
+          <a:fillRef idx="3">
+            <a:schemeClr val="accent1"/>
+          </a:fillRef>
+          <a:effectRef idx="2">
+            <a:schemeClr val="accent1"/>
+          </a:effectRef>
+          <a:fontRef idx="minor">
+            <a:schemeClr val="lt1"/>
+          </a:fontRef>
+        </p:style>
+        <p:txBody>
+          <a:bodyPr rtlCol="0" anchor="ctr" wrap="square"/>
+          <a:lstStyle/>
+          <a:p>
+            <a:pPr algn="ctr">
+              <a:defRPr sz="2400" b="1">
+                <a:solidFill>
+                  <a:srgbClr val="FFFFFF"/>
+                </a:solidFill>
+                <a:latin typeface="Calibri"/>
+              </a:defRPr>
+            </a:pPr>
+            <a:r>
+              <a:t>The interesting question isn't "how much can we automate?"</a:t>
+            </a:r>
+            <a:br/>
+            <a:r>
+              <a:t>It's "how much should we, and who decides?"</a:t>
             </a:r>
           </a:p>
         </p:txBody>
@@ -7905,8 +7751,44 @@
         </p:nvSpPr>
         <p:spPr>
           <a:xfrm>
-            <a:off x="731520" y="365760"/>
-            <a:ext cx="10698480" cy="822960"/>
+            <a:off x="914400" y="1371600"/>
+            <a:ext cx="10332720" cy="1828800"/>
+          </a:xfrm>
+          <a:prstGeom prst="rect">
+            <a:avLst/>
+          </a:prstGeom>
+          <a:noFill/>
+        </p:spPr>
+        <p:txBody>
+          <a:bodyPr wrap="none">
+            <a:spAutoFit/>
+          </a:bodyPr>
+          <a:lstStyle/>
+          <a:p>
+            <a:pPr algn="ctr">
+              <a:defRPr sz="9600" b="1">
+                <a:solidFill>
+                  <a:srgbClr val="550000"/>
+                </a:solidFill>
+                <a:latin typeface="Calibri"/>
+              </a:defRPr>
+            </a:pPr>
+            <a:r>
+              <a:t>06</a:t>
+            </a:r>
+          </a:p>
+        </p:txBody>
+      </p:sp>
+      <p:sp>
+        <p:nvSpPr>
+          <p:cNvPr id="4" name="TextBox 3"/>
+          <p:cNvSpPr txBox="1"/>
+          <p:nvPr/>
+        </p:nvSpPr>
+        <p:spPr>
+          <a:xfrm>
+            <a:off x="914400" y="3200400"/>
+            <a:ext cx="10332720" cy="1097280"/>
           </a:xfrm>
           <a:prstGeom prst="rect">
             <a:avLst/>
@@ -7919,8 +7801,8 @@
           </a:bodyPr>
           <a:lstStyle/>
           <a:p>
-            <a:pPr algn="l">
-              <a:defRPr sz="3600" b="1">
+            <a:pPr algn="ctr">
+              <a:defRPr sz="4800" b="1">
                 <a:solidFill>
                   <a:srgbClr val="FFFFFF"/>
                 </a:solidFill>
@@ -7928,21 +7810,21 @@
               </a:defRPr>
             </a:pPr>
             <a:r>
-              <a:t>Being pragmatic</a:t>
-            </a:r>
-          </a:p>
-        </p:txBody>
-      </p:sp>
-      <p:sp>
-        <p:nvSpPr>
-          <p:cNvPr id="4" name="TextBox 3"/>
+              <a:t>Live demo</a:t>
+            </a:r>
+          </a:p>
+        </p:txBody>
+      </p:sp>
+      <p:sp>
+        <p:nvSpPr>
+          <p:cNvPr id="5" name="TextBox 4"/>
           <p:cNvSpPr txBox="1"/>
           <p:nvPr/>
         </p:nvSpPr>
         <p:spPr>
           <a:xfrm>
-            <a:off x="731520" y="1371600"/>
-            <a:ext cx="10698480" cy="2560320"/>
+            <a:off x="914400" y="4297680"/>
+            <a:ext cx="10332720" cy="731520"/>
           </a:xfrm>
           <a:prstGeom prst="rect">
             <a:avLst/>
@@ -7955,148 +7837,16 @@
           </a:bodyPr>
           <a:lstStyle/>
           <a:p>
-            <a:pPr algn="l">
+            <a:pPr algn="ctr">
               <a:defRPr sz="2400" b="0">
                 <a:solidFill>
-                  <a:srgbClr val="F2F2F2"/>
-                </a:solidFill>
-                <a:latin typeface="Calibri"/>
-              </a:defRPr>
-            </a:pPr>
-          </a:p>
-          <a:p>
-            <a:pPr>
-              <a:spcBef>
-                <a:spcPts val="600"/>
-              </a:spcBef>
-              <a:spcAft>
-                <a:spcPts val="400"/>
-              </a:spcAft>
-              <a:defRPr sz="2400" b="0">
-                <a:solidFill>
-                  <a:srgbClr val="F2F2F2"/>
-                </a:solidFill>
-                <a:latin typeface="Calibri"/>
-              </a:defRPr>
-            </a:pPr>
-            <a:r>
-              <a:t>Slack reports give me visibility without touching anyone's PRs</a:t>
-            </a:r>
-          </a:p>
-          <a:p>
-            <a:pPr>
-              <a:spcBef>
-                <a:spcPts val="600"/>
-              </a:spcBef>
-              <a:spcAft>
-                <a:spcPts val="400"/>
-              </a:spcAft>
-              <a:defRPr sz="2400" b="0">
-                <a:solidFill>
-                  <a:srgbClr val="F2F2F2"/>
-                </a:solidFill>
-                <a:latin typeface="Calibri"/>
-              </a:defRPr>
-            </a:pPr>
-            <a:r>
-              <a:t>I ask before enabling actions on a project</a:t>
-            </a:r>
-          </a:p>
-          <a:p>
-            <a:pPr>
-              <a:spcBef>
-                <a:spcPts val="600"/>
-              </a:spcBef>
-              <a:spcAft>
-                <a:spcPts val="400"/>
-              </a:spcAft>
-              <a:defRPr sz="2400" b="1">
-                <a:solidFill>
-                  <a:srgbClr val="F2F2F2"/>
-                </a:solidFill>
-                <a:latin typeface="Calibri"/>
-              </a:defRPr>
-            </a:pPr>
-            <a:r>
-              <a:t>The tool has a dial because I learned I needed one</a:t>
-            </a:r>
-          </a:p>
-          <a:p>
-            <a:pPr>
-              <a:spcBef>
-                <a:spcPts val="600"/>
-              </a:spcBef>
-              <a:spcAft>
-                <a:spcPts val="400"/>
-              </a:spcAft>
-              <a:defRPr sz="2400" b="1">
-                <a:solidFill>
-                  <a:srgbClr val="F2F2F2"/>
-                </a:solidFill>
-                <a:latin typeface="Calibri"/>
-              </a:defRPr>
-            </a:pPr>
-            <a:r>
-              <a:t>Don't enter AI psychosis. Be pragmatic.</a:t>
-            </a:r>
-          </a:p>
-        </p:txBody>
-      </p:sp>
-      <p:sp>
-        <p:nvSpPr>
-          <p:cNvPr id="5" name="Rectangle 4"/>
-          <p:cNvSpPr/>
-          <p:nvPr/>
-        </p:nvSpPr>
-        <p:spPr>
-          <a:xfrm>
-            <a:off x="1371600" y="4114800"/>
-            <a:ext cx="9418320" cy="1097280"/>
-          </a:xfrm>
-          <a:prstGeom prst="rect">
-            <a:avLst/>
-          </a:prstGeom>
-          <a:solidFill>
-            <a:srgbClr val="1A0A0A"/>
-          </a:solidFill>
-          <a:ln>
-            <a:solidFill>
-              <a:srgbClr val="550000"/>
-            </a:solidFill>
-          </a:ln>
-        </p:spPr>
-        <p:style>
-          <a:lnRef idx="1">
-            <a:schemeClr val="accent1"/>
-          </a:lnRef>
-          <a:fillRef idx="3">
-            <a:schemeClr val="accent1"/>
-          </a:fillRef>
-          <a:effectRef idx="2">
-            <a:schemeClr val="accent1"/>
-          </a:effectRef>
-          <a:fontRef idx="minor">
-            <a:schemeClr val="lt1"/>
-          </a:fontRef>
-        </p:style>
-        <p:txBody>
-          <a:bodyPr rtlCol="0" anchor="ctr" wrap="square"/>
-          <a:lstStyle/>
-          <a:p>
-            <a:pPr algn="ctr">
-              <a:defRPr sz="2400" b="1">
-                <a:solidFill>
-                  <a:srgbClr val="FFFFFF"/>
-                </a:solidFill>
-                <a:latin typeface="Calibri"/>
-              </a:defRPr>
-            </a:pPr>
-            <a:r>
-              <a:t>The interesting question isn't "how much can we automate?"</a:t>
-            </a:r>
-            <a:br/>
-            <a:r>
-              <a:t>It's "how much should we, and who decides?"</a:t>
+                  <a:srgbClr val="6A6E73"/>
+                </a:solidFill>
+                <a:latin typeface="Calibri"/>
+              </a:defRPr>
+            </a:pPr>
+            <a:r>
+              <a:t>The factory floor</a:t>
             </a:r>
           </a:p>
         </p:txBody>
@@ -8319,8 +8069,8 @@
         </p:nvSpPr>
         <p:spPr>
           <a:xfrm>
-            <a:off x="914400" y="1371600"/>
-            <a:ext cx="10332720" cy="1828800"/>
+            <a:off x="731520" y="365760"/>
+            <a:ext cx="10698480" cy="822960"/>
           </a:xfrm>
           <a:prstGeom prst="rect">
             <a:avLst/>
@@ -8328,21 +8078,21 @@
           <a:noFill/>
         </p:spPr>
         <p:txBody>
-          <a:bodyPr wrap="none">
+          <a:bodyPr wrap="square">
             <a:spAutoFit/>
           </a:bodyPr>
           <a:lstStyle/>
           <a:p>
-            <a:pPr algn="ctr">
-              <a:defRPr sz="9600" b="1">
-                <a:solidFill>
-                  <a:srgbClr val="550000"/>
-                </a:solidFill>
-                <a:latin typeface="Calibri"/>
-              </a:defRPr>
-            </a:pPr>
-            <a:r>
-              <a:t>06</a:t>
+            <a:pPr algn="l">
+              <a:defRPr sz="3600" b="1">
+                <a:solidFill>
+                  <a:srgbClr val="FFFFFF"/>
+                </a:solidFill>
+                <a:latin typeface="Calibri"/>
+              </a:defRPr>
+            </a:pPr>
+            <a:r>
+              <a:t>What you're about to see</a:t>
             </a:r>
           </a:p>
         </p:txBody>
@@ -8355,8 +8105,8 @@
         </p:nvSpPr>
         <p:spPr>
           <a:xfrm>
-            <a:off x="914400" y="3200400"/>
-            <a:ext cx="10332720" cy="1097280"/>
+            <a:off x="731520" y="1371600"/>
+            <a:ext cx="10698480" cy="4114800"/>
           </a:xfrm>
           <a:prstGeom prst="rect">
             <a:avLst/>
@@ -8369,16 +8119,108 @@
           </a:bodyPr>
           <a:lstStyle/>
           <a:p>
-            <a:pPr algn="ctr">
-              <a:defRPr sz="4800" b="1">
-                <a:solidFill>
-                  <a:srgbClr val="FFFFFF"/>
-                </a:solidFill>
-                <a:latin typeface="Calibri"/>
-              </a:defRPr>
-            </a:pPr>
-            <a:r>
-              <a:t>Live demo</a:t>
+            <a:pPr algn="l">
+              <a:defRPr sz="2400" b="0">
+                <a:solidFill>
+                  <a:srgbClr val="F2F2F2"/>
+                </a:solidFill>
+                <a:latin typeface="Calibri"/>
+              </a:defRPr>
+            </a:pPr>
+          </a:p>
+          <a:p>
+            <a:pPr>
+              <a:spcBef>
+                <a:spcPts val="600"/>
+              </a:spcBef>
+              <a:spcAft>
+                <a:spcPts val="400"/>
+              </a:spcAft>
+              <a:defRPr sz="2400" b="1">
+                <a:solidFill>
+                  <a:srgbClr val="F2F2F2"/>
+                </a:solidFill>
+                <a:latin typeface="Calibri"/>
+              </a:defRPr>
+            </a:pPr>
+            <a:r>
+              <a:t>The TUI -- real-time view of every oompa working</a:t>
+            </a:r>
+          </a:p>
+          <a:p>
+            <a:pPr>
+              <a:spcBef>
+                <a:spcPts val="600"/>
+              </a:spcBef>
+              <a:spcAft>
+                <a:spcPts val="400"/>
+              </a:spcAft>
+              <a:defRPr sz="2400" b="0">
+                <a:solidFill>
+                  <a:srgbClr val="F2F2F2"/>
+                </a:solidFill>
+                <a:latin typeface="Calibri"/>
+              </a:defRPr>
+            </a:pPr>
+            <a:r>
+              <a:t>Each project gets a super box with its oompas inside</a:t>
+            </a:r>
+          </a:p>
+          <a:p>
+            <a:pPr>
+              <a:spcBef>
+                <a:spcPts val="600"/>
+              </a:spcBef>
+              <a:spcAft>
+                <a:spcPts val="400"/>
+              </a:spcAft>
+              <a:defRPr sz="2400" b="0">
+                <a:solidFill>
+                  <a:srgbClr val="F2F2F2"/>
+                </a:solidFill>
+                <a:latin typeface="Calibri"/>
+              </a:defRPr>
+            </a:pPr>
+            <a:r>
+              <a:t>Animated sprites -- ladder-climbing (rebasing), hammer-swinging (working), sleeping (Zzz), magnifying glass (reviewing)</a:t>
+            </a:r>
+          </a:p>
+          <a:p>
+            <a:pPr>
+              <a:spcBef>
+                <a:spcPts val="600"/>
+              </a:spcBef>
+              <a:spcAft>
+                <a:spcPts val="400"/>
+              </a:spcAft>
+              <a:defRPr sz="2400" b="1">
+                <a:solidFill>
+                  <a:srgbClr val="F2F2F2"/>
+                </a:solidFill>
+                <a:latin typeface="Calibri"/>
+              </a:defRPr>
+            </a:pPr>
+            <a:r>
+              <a:t>Slack notifications from the live service</a:t>
+            </a:r>
+          </a:p>
+          <a:p>
+            <a:pPr>
+              <a:spcBef>
+                <a:spcPts val="600"/>
+              </a:spcBef>
+              <a:spcAft>
+                <a:spcPts val="400"/>
+              </a:spcAft>
+              <a:defRPr sz="2400" b="0">
+                <a:solidFill>
+                  <a:srgbClr val="F2F2F2"/>
+                </a:solidFill>
+                <a:latin typeface="Calibri"/>
+              </a:defRPr>
+            </a:pPr>
+            <a:r>
+              <a:t>oompa status --events -- filtered event stream</a:t>
             </a:r>
           </a:p>
         </p:txBody>
@@ -8391,8 +8233,8 @@
         </p:nvSpPr>
         <p:spPr>
           <a:xfrm>
-            <a:off x="914400" y="4297680"/>
-            <a:ext cx="10332720" cy="731520"/>
+            <a:off x="731520" y="5303520"/>
+            <a:ext cx="10698480" cy="548640"/>
           </a:xfrm>
           <a:prstGeom prst="rect">
             <a:avLst/>
@@ -8406,7 +8248,7 @@
           <a:lstStyle/>
           <a:p>
             <a:pPr algn="ctr">
-              <a:defRPr sz="2400" b="0">
+              <a:defRPr sz="2200" b="0">
                 <a:solidFill>
                   <a:srgbClr val="6A6E73"/>
                 </a:solidFill>
@@ -8414,7 +8256,7 @@
               </a:defRPr>
             </a:pPr>
             <a:r>
-              <a:t>The factory floor</a:t>
+              <a:t>The oompas on screen are the ones I have permission to run.</a:t>
             </a:r>
           </a:p>
         </p:txBody>
@@ -8428,275 +8270,6 @@
 </file>
 
 <file path=ppt/slides/slide21.xml><?xml version="1.0" encoding="utf-8"?>
-<p:sld xmlns:a="http://schemas.openxmlformats.org/drawingml/2006/main" xmlns:p="http://schemas.openxmlformats.org/presentationml/2006/main" xmlns:r="http://schemas.openxmlformats.org/officeDocument/2006/relationships">
-  <p:cSld>
-    <p:bg>
-      <p:bgPr>
-        <a:solidFill>
-          <a:srgbClr val="151515"/>
-        </a:solidFill>
-        <a:effectLst/>
-      </p:bgPr>
-    </p:bg>
-    <p:spTree>
-      <p:nvGrpSpPr>
-        <p:cNvPr id="1" name=""/>
-        <p:cNvGrpSpPr/>
-        <p:nvPr/>
-      </p:nvGrpSpPr>
-      <p:grpSpPr/>
-      <p:sp>
-        <p:nvSpPr>
-          <p:cNvPr id="2" name="Rectangle 1"/>
-          <p:cNvSpPr/>
-          <p:nvPr/>
-        </p:nvSpPr>
-        <p:spPr>
-          <a:xfrm>
-            <a:off x="0" y="6781800"/>
-            <a:ext cx="12191695" cy="76200"/>
-          </a:xfrm>
-          <a:prstGeom prst="rect">
-            <a:avLst/>
-          </a:prstGeom>
-          <a:solidFill>
-            <a:srgbClr val="EE0000"/>
-          </a:solidFill>
-          <a:ln>
-            <a:noFill/>
-          </a:ln>
-        </p:spPr>
-        <p:style>
-          <a:lnRef idx="1">
-            <a:schemeClr val="accent1"/>
-          </a:lnRef>
-          <a:fillRef idx="3">
-            <a:schemeClr val="accent1"/>
-          </a:fillRef>
-          <a:effectRef idx="2">
-            <a:schemeClr val="accent1"/>
-          </a:effectRef>
-          <a:fontRef idx="minor">
-            <a:schemeClr val="lt1"/>
-          </a:fontRef>
-        </p:style>
-        <p:txBody>
-          <a:bodyPr rtlCol="0" anchor="ctr"/>
-          <a:lstStyle/>
-          <a:p>
-            <a:pPr algn="ctr"/>
-          </a:p>
-        </p:txBody>
-      </p:sp>
-      <p:sp>
-        <p:nvSpPr>
-          <p:cNvPr id="3" name="TextBox 2"/>
-          <p:cNvSpPr txBox="1"/>
-          <p:nvPr/>
-        </p:nvSpPr>
-        <p:spPr>
-          <a:xfrm>
-            <a:off x="731520" y="365760"/>
-            <a:ext cx="10698480" cy="822960"/>
-          </a:xfrm>
-          <a:prstGeom prst="rect">
-            <a:avLst/>
-          </a:prstGeom>
-          <a:noFill/>
-        </p:spPr>
-        <p:txBody>
-          <a:bodyPr wrap="square">
-            <a:spAutoFit/>
-          </a:bodyPr>
-          <a:lstStyle/>
-          <a:p>
-            <a:pPr algn="l">
-              <a:defRPr sz="3600" b="1">
-                <a:solidFill>
-                  <a:srgbClr val="FFFFFF"/>
-                </a:solidFill>
-                <a:latin typeface="Calibri"/>
-              </a:defRPr>
-            </a:pPr>
-            <a:r>
-              <a:t>What you're about to see</a:t>
-            </a:r>
-          </a:p>
-        </p:txBody>
-      </p:sp>
-      <p:sp>
-        <p:nvSpPr>
-          <p:cNvPr id="4" name="TextBox 3"/>
-          <p:cNvSpPr txBox="1"/>
-          <p:nvPr/>
-        </p:nvSpPr>
-        <p:spPr>
-          <a:xfrm>
-            <a:off x="731520" y="1371600"/>
-            <a:ext cx="10698480" cy="4114800"/>
-          </a:xfrm>
-          <a:prstGeom prst="rect">
-            <a:avLst/>
-          </a:prstGeom>
-          <a:noFill/>
-        </p:spPr>
-        <p:txBody>
-          <a:bodyPr wrap="square">
-            <a:spAutoFit/>
-          </a:bodyPr>
-          <a:lstStyle/>
-          <a:p>
-            <a:pPr algn="l">
-              <a:defRPr sz="2400" b="0">
-                <a:solidFill>
-                  <a:srgbClr val="F2F2F2"/>
-                </a:solidFill>
-                <a:latin typeface="Calibri"/>
-              </a:defRPr>
-            </a:pPr>
-          </a:p>
-          <a:p>
-            <a:pPr>
-              <a:spcBef>
-                <a:spcPts val="600"/>
-              </a:spcBef>
-              <a:spcAft>
-                <a:spcPts val="400"/>
-              </a:spcAft>
-              <a:defRPr sz="2400" b="1">
-                <a:solidFill>
-                  <a:srgbClr val="F2F2F2"/>
-                </a:solidFill>
-                <a:latin typeface="Calibri"/>
-              </a:defRPr>
-            </a:pPr>
-            <a:r>
-              <a:t>The TUI -- real-time view of every oompa working</a:t>
-            </a:r>
-          </a:p>
-          <a:p>
-            <a:pPr>
-              <a:spcBef>
-                <a:spcPts val="600"/>
-              </a:spcBef>
-              <a:spcAft>
-                <a:spcPts val="400"/>
-              </a:spcAft>
-              <a:defRPr sz="2400" b="0">
-                <a:solidFill>
-                  <a:srgbClr val="F2F2F2"/>
-                </a:solidFill>
-                <a:latin typeface="Calibri"/>
-              </a:defRPr>
-            </a:pPr>
-            <a:r>
-              <a:t>Each project gets a super box with its oompas inside</a:t>
-            </a:r>
-          </a:p>
-          <a:p>
-            <a:pPr>
-              <a:spcBef>
-                <a:spcPts val="600"/>
-              </a:spcBef>
-              <a:spcAft>
-                <a:spcPts val="400"/>
-              </a:spcAft>
-              <a:defRPr sz="2400" b="0">
-                <a:solidFill>
-                  <a:srgbClr val="F2F2F2"/>
-                </a:solidFill>
-                <a:latin typeface="Calibri"/>
-              </a:defRPr>
-            </a:pPr>
-            <a:r>
-              <a:t>Animated sprites -- ladder-climbing (rebasing), hammer-swinging (working), sleeping (Zzz), magnifying glass (reviewing)</a:t>
-            </a:r>
-          </a:p>
-          <a:p>
-            <a:pPr>
-              <a:spcBef>
-                <a:spcPts val="600"/>
-              </a:spcBef>
-              <a:spcAft>
-                <a:spcPts val="400"/>
-              </a:spcAft>
-              <a:defRPr sz="2400" b="1">
-                <a:solidFill>
-                  <a:srgbClr val="F2F2F2"/>
-                </a:solidFill>
-                <a:latin typeface="Calibri"/>
-              </a:defRPr>
-            </a:pPr>
-            <a:r>
-              <a:t>Slack notifications from the live service</a:t>
-            </a:r>
-          </a:p>
-          <a:p>
-            <a:pPr>
-              <a:spcBef>
-                <a:spcPts val="600"/>
-              </a:spcBef>
-              <a:spcAft>
-                <a:spcPts val="400"/>
-              </a:spcAft>
-              <a:defRPr sz="2400" b="0">
-                <a:solidFill>
-                  <a:srgbClr val="F2F2F2"/>
-                </a:solidFill>
-                <a:latin typeface="Calibri"/>
-              </a:defRPr>
-            </a:pPr>
-            <a:r>
-              <a:t>oompa status --events -- filtered event stream</a:t>
-            </a:r>
-          </a:p>
-        </p:txBody>
-      </p:sp>
-      <p:sp>
-        <p:nvSpPr>
-          <p:cNvPr id="5" name="TextBox 4"/>
-          <p:cNvSpPr txBox="1"/>
-          <p:nvPr/>
-        </p:nvSpPr>
-        <p:spPr>
-          <a:xfrm>
-            <a:off x="731520" y="5303520"/>
-            <a:ext cx="10698480" cy="548640"/>
-          </a:xfrm>
-          <a:prstGeom prst="rect">
-            <a:avLst/>
-          </a:prstGeom>
-          <a:noFill/>
-        </p:spPr>
-        <p:txBody>
-          <a:bodyPr wrap="square">
-            <a:spAutoFit/>
-          </a:bodyPr>
-          <a:lstStyle/>
-          <a:p>
-            <a:pPr algn="ctr">
-              <a:defRPr sz="2200" b="0">
-                <a:solidFill>
-                  <a:srgbClr val="6A6E73"/>
-                </a:solidFill>
-                <a:latin typeface="Calibri"/>
-              </a:defRPr>
-            </a:pPr>
-            <a:r>
-              <a:t>The oompas on screen are the ones I have permission to run.</a:t>
-            </a:r>
-          </a:p>
-        </p:txBody>
-      </p:sp>
-    </p:spTree>
-  </p:cSld>
-  <p:clrMapOvr>
-    <a:masterClrMapping/>
-  </p:clrMapOvr>
-</p:sld>
-</file>
-
-<file path=ppt/slides/slide22.xml><?xml version="1.0" encoding="utf-8"?>
 <p:sld xmlns:a="http://schemas.openxmlformats.org/drawingml/2006/main" xmlns:p="http://schemas.openxmlformats.org/presentationml/2006/main" xmlns:r="http://schemas.openxmlformats.org/officeDocument/2006/relationships">
   <p:cSld>
     <p:bg>

</xml_diff>

<commit_message>
docs: use real config.yaml in presentation config slide
</commit_message>
<xml_diff>
--- a/docs/oompa-presentation.pptx
+++ b/docs/oompa-presentation.pptx
@@ -9800,7 +9800,7 @@
         <p:spPr>
           <a:xfrm>
             <a:off x="731520" y="1280160"/>
-            <a:ext cx="10698480" cy="3840480"/>
+            <a:ext cx="10698480" cy="5303520"/>
           </a:xfrm>
           <a:prstGeom prst="rect">
             <a:avLst/>
@@ -9845,7 +9845,7 @@
         <p:spPr>
           <a:xfrm>
             <a:off x="914400" y="1371600"/>
-            <a:ext cx="10332720" cy="3657600"/>
+            <a:ext cx="10332720" cy="5212080"/>
           </a:xfrm>
           <a:prstGeom prst="rect">
             <a:avLst/>
@@ -9859,7 +9859,7 @@
           <a:lstStyle/>
           <a:p>
             <a:pPr algn="l">
-              <a:defRPr sz="1700" b="0">
+              <a:defRPr sz="1100" b="0">
                 <a:solidFill>
                   <a:srgbClr val="F2F2F2"/>
                 </a:solidFill>
@@ -9867,135 +9867,236 @@
               </a:defRPr>
             </a:pPr>
             <a:r>
-              <a:t>projects:</a:t>
+              <a:t># Global settings</a:t>
             </a:r>
             <a:br/>
             <a:r>
-              <a:t>  - owner: ovn-org</a:t>
+              <a:t>agent: opencode</a:t>
             </a:r>
             <a:br/>
             <a:r>
-              <a:t>    repo: ovn-kubernetes</a:t>
+              <a:t>agent-model: google-vertex-anthropic/claude-opus-4-6@default</a:t>
             </a:r>
             <a:br/>
             <a:r>
-              <a:t>    roles: [prs]</a:t>
+              <a:t>poll-interval: 2m</a:t>
             </a:r>
             <a:br/>
             <a:r>
-              <a:t>    reactions: []              # report-only -- just watch</a:t>
+              <a:t>log-level: debug</a:t>
+            </a:r>
+            <a:br/>
+            <a:r>
+              <a:t>exit-on-new-version: qinqon/oompa</a:t>
             </a:r>
             <a:br/>
             <a:br/>
             <a:r>
-              <a:t>  - owner: nmstate</a:t>
+              <a:t>projects:</a:t>
             </a:r>
             <a:br/>
             <a:r>
-              <a:t>    repo: kubernetes-nmstate</a:t>
+              <a:t>  # --- ovn-kubernetes: report-only (no reactions, Slack reporting only) ---</a:t>
             </a:r>
             <a:br/>
             <a:r>
-              <a:t>    roles: [prs, issues, triage]</a:t>
+              <a:t>  - repo: ovn-kubernetes/ovn-kubernetes</a:t>
             </a:r>
             <a:br/>
             <a:r>
-              <a:t>    reactions: [ci, rebase, review]</a:t>
+              <a:t>    flaky-label: kind/ci-flake</a:t>
+            </a:r>
+            <a:br/>
+            <a:r>
+              <a:t>    prs:</a:t>
+            </a:r>
+            <a:br/>
+            <a:r>
+              <a:t>      - watch: [6466]</a:t>
+            </a:r>
+            <a:br/>
+            <a:r>
+              <a:t>        reactions: []</a:t>
             </a:r>
             <a:br/>
             <a:br/>
             <a:r>
-              <a:t>  - owner: qinqon</a:t>
+              <a:t>  # --- hypershift: PR babysitter with reviews ---</a:t>
             </a:r>
             <a:br/>
             <a:r>
-              <a:t>    repo: oompa</a:t>
+              <a:t>  - repo: openshift/hypershift</a:t>
             </a:r>
             <a:br/>
             <a:r>
-              <a:t>    roles: [prs, issues]</a:t>
+              <a:t>    fork: qinqon/hypershift</a:t>
             </a:r>
             <a:br/>
             <a:r>
-              <a:t>    reactions: [ci, rebase, review]</a:t>
+              <a:t>    create-flaky-issues: false</a:t>
             </a:r>
             <a:br/>
             <a:r>
-              <a:t>    skip-checks: [can-be-merged]</a:t>
-            </a:r>
-          </a:p>
-        </p:txBody>
-      </p:sp>
-      <p:sp>
-        <p:nvSpPr>
-          <p:cNvPr id="6" name="TextBox 5"/>
-          <p:cNvSpPr txBox="1"/>
-          <p:nvPr/>
-        </p:nvSpPr>
-        <p:spPr>
-          <a:xfrm>
-            <a:off x="731520" y="5303520"/>
-            <a:ext cx="10698480" cy="914400"/>
-          </a:xfrm>
-          <a:prstGeom prst="rect">
-            <a:avLst/>
-          </a:prstGeom>
-          <a:noFill/>
-        </p:spPr>
-        <p:txBody>
-          <a:bodyPr wrap="square">
-            <a:spAutoFit/>
-          </a:bodyPr>
-          <a:lstStyle/>
-          <a:p>
-            <a:pPr algn="l">
-              <a:defRPr sz="1800" b="0">
-                <a:solidFill>
-                  <a:srgbClr val="6A6E73"/>
-                </a:solidFill>
-                <a:latin typeface="Calibri"/>
-              </a:defRPr>
-            </a:pPr>
-            <a:r>
-              <a:t>Each project gets its own level of automation.</a:t>
-            </a:r>
-          </a:p>
-          <a:p>
-            <a:pPr algn="l">
-              <a:spcBef>
-                <a:spcPts val="800"/>
-              </a:spcBef>
-              <a:spcAft>
-                <a:spcPts val="400"/>
-              </a:spcAft>
-              <a:defRPr sz="1800" b="0">
-                <a:solidFill>
-                  <a:srgbClr val="6A6E73"/>
-                </a:solidFill>
-                <a:latin typeface="Calibri"/>
-              </a:defRPr>
-            </a:pPr>
-            <a:r>
-              <a:t>reactions: []  means oompa watches but does nothing.</a:t>
-            </a:r>
-          </a:p>
-          <a:p>
-            <a:pPr algn="l">
-              <a:spcBef>
-                <a:spcPts val="800"/>
-              </a:spcBef>
-              <a:spcAft>
-                <a:spcPts val="400"/>
-              </a:spcAft>
-              <a:defRPr sz="1800" b="1">
-                <a:solidFill>
-                  <a:srgbClr val="6A6E73"/>
-                </a:solidFill>
-                <a:latin typeface="Calibri"/>
-              </a:defRPr>
-            </a:pPr>
-            <a:r>
-              <a:t>This dial exists because I learned I needed it.</a:t>
+              <a:t>    flaky-label: kind/flake</a:t>
+            </a:r>
+            <a:br/>
+            <a:r>
+              <a:t>    reviewers:</a:t>
+            </a:r>
+            <a:br/>
+            <a:r>
+              <a:t>      - "coderabbitai[bot]"</a:t>
+            </a:r>
+            <a:br/>
+            <a:r>
+              <a:t>      - nunnatsa</a:t>
+            </a:r>
+            <a:br/>
+            <a:r>
+              <a:t>      - orenc1</a:t>
+            </a:r>
+            <a:br/>
+            <a:r>
+              <a:t>      - awels</a:t>
+            </a:r>
+            <a:br/>
+            <a:r>
+              <a:t>      - akalenyu</a:t>
+            </a:r>
+            <a:br/>
+            <a:r>
+              <a:t>      - enxebre</a:t>
+            </a:r>
+            <a:br/>
+            <a:r>
+              <a:t>    prs:</a:t>
+            </a:r>
+            <a:br/>
+            <a:r>
+              <a:t>      - watch: [8365]</a:t>
+            </a:r>
+            <a:br/>
+            <a:r>
+              <a:t>        reactions: [ci, conflicts]  # no rebase -- Prow handles this</a:t>
+            </a:r>
+            <a:br/>
+            <a:br/>
+            <a:r>
+              <a:t>  # --- kubernetes-nmstate: issue resolver + periodic triage ---</a:t>
+            </a:r>
+            <a:br/>
+            <a:r>
+              <a:t>  - repo: nmstate/kubernetes-nmstate</a:t>
+            </a:r>
+            <a:br/>
+            <a:r>
+              <a:t>    fork: qinqon/kubernetes-nmstate</a:t>
+            </a:r>
+            <a:br/>
+            <a:r>
+              <a:t>    issues:</a:t>
+            </a:r>
+            <a:br/>
+            <a:r>
+              <a:t>      - only-assigned: true</a:t>
+            </a:r>
+            <a:br/>
+            <a:r>
+              <a:t>    triage:</a:t>
+            </a:r>
+            <a:br/>
+            <a:r>
+              <a:t>      - jobs:</a:t>
+            </a:r>
+            <a:br/>
+            <a:r>
+              <a:t>          - https://prow.ci.kubevirt.io/view/gs/kubevirt-prow/...</a:t>
+            </a:r>
+            <a:br/>
+            <a:r>
+              <a:t>        schedule: "09:00 Europe/Madrid"</a:t>
+            </a:r>
+            <a:br/>
+            <a:r>
+              <a:t>        create-flaky-issues: true</a:t>
+            </a:r>
+            <a:br/>
+            <a:r>
+              <a:t>        flaky-label: ci-flake</a:t>
+            </a:r>
+            <a:br/>
+            <a:br/>
+            <a:r>
+              <a:t>  # --- openshift-virtualization-tests: PR babysitter ---</a:t>
+            </a:r>
+            <a:br/>
+            <a:r>
+              <a:t>  - repo: RedHatQE/openshift-virtualization-tests</a:t>
+            </a:r>
+            <a:br/>
+            <a:r>
+              <a:t>    fork: qinqon/openshift-virtualization-tests</a:t>
+            </a:r>
+            <a:br/>
+            <a:r>
+              <a:t>    rebase-interval: 24h</a:t>
+            </a:r>
+            <a:br/>
+            <a:r>
+              <a:t>    prs:</a:t>
+            </a:r>
+            <a:br/>
+            <a:r>
+              <a:t>      - watch: [4770]</a:t>
+            </a:r>
+            <a:br/>
+            <a:r>
+              <a:t>        reactions: [ci, conflicts, rebase]</a:t>
+            </a:r>
+            <a:br/>
+            <a:r>
+              <a:t>        skip-comment: [rebase]</a:t>
+            </a:r>
+            <a:br/>
+            <a:r>
+              <a:t>        skip-checks: [can-be-merged, verified, verify-bugs-are-open]</a:t>
+            </a:r>
+            <a:br/>
+            <a:br/>
+            <a:r>
+              <a:t>  # --- oompa: issue resolver (self-maintaining) ---</a:t>
+            </a:r>
+            <a:br/>
+            <a:r>
+              <a:t>  - repo: qinqon/oompa</a:t>
+            </a:r>
+            <a:br/>
+            <a:r>
+              <a:t>    reviewers:</a:t>
+            </a:r>
+            <a:br/>
+            <a:r>
+              <a:t>      - qinqon</a:t>
+            </a:r>
+            <a:br/>
+            <a:r>
+              <a:t>      - "gemini-code-assist[bot]"</a:t>
+            </a:r>
+            <a:br/>
+            <a:r>
+              <a:t>      - "coderabbitai[bot]"</a:t>
+            </a:r>
+            <a:br/>
+            <a:r>
+              <a:t>      - "copilot-pull-request-reviewer[bot]"</a:t>
+            </a:r>
+            <a:br/>
+            <a:r>
+              <a:t>    issues:</a:t>
+            </a:r>
+            <a:br/>
+            <a:r>
+              <a:t>      - label: good-for-ai</a:t>
             </a:r>
           </a:p>
         </p:txBody>

</xml_diff>